<commit_message>
Added weights and biases
</commit_message>
<xml_diff>
--- a/Baseline_Presentation.pptx
+++ b/Baseline_Presentation.pptx
@@ -13,6 +13,7 @@
     <p:sldId id="263" r:id="rId9"/>
     <p:sldId id="264" r:id="rId13"/>
     <p:sldId id="265" r:id="rId14"/>
+    <p:sldId id="266" r:id="rId15"/>
   </p:sldIdLst>
   <p:sldSz cx="9144000" cy="6858000" type="screen4x3"/>
   <p:notesSz cx="6858000" cy="9144000"/>
@@ -4444,6 +4445,243 @@
             </a:pPr>
             <a:r>
               <a:t>evaluator = LLMJudgeRouterReward(model='claude-opus-4-1')</a:t>
+            </a:r>
+          </a:p>
+        </p:txBody>
+      </p:sp>
+    </p:spTree>
+  </p:cSld>
+  <p:clrMapOvr>
+    <a:masterClrMapping/>
+  </p:clrMapOvr>
+</p:sld>
+</file>
+
+<file path=ppt/slides/slide9.xml><?xml version="1.0" encoding="utf-8"?>
+<p:sld xmlns:a="http://schemas.openxmlformats.org/drawingml/2006/main" xmlns:p="http://schemas.openxmlformats.org/presentationml/2006/main" xmlns:r="http://schemas.openxmlformats.org/officeDocument/2006/relationships">
+  <p:cSld>
+    <p:spTree>
+      <p:nvGrpSpPr>
+        <p:cNvPr id="1" name=""/>
+        <p:cNvGrpSpPr/>
+        <p:nvPr/>
+      </p:nvGrpSpPr>
+      <p:grpSpPr/>
+      <p:sp>
+        <p:nvSpPr>
+          <p:cNvPr id="2" name="Title 1"/>
+          <p:cNvSpPr>
+            <a:spLocks noGrp="1"/>
+          </p:cNvSpPr>
+          <p:nvPr>
+            <p:ph type="title"/>
+          </p:nvPr>
+        </p:nvSpPr>
+        <p:spPr/>
+        <p:txBody>
+          <a:bodyPr/>
+          <a:lstStyle/>
+          <a:p>
+            <a:r>
+              <a:t>Solver Rewards: Incentivizing Tool Use</a:t>
+            </a:r>
+          </a:p>
+        </p:txBody>
+      </p:sp>
+      <p:sp>
+        <p:nvSpPr>
+          <p:cNvPr id="3" name="Content Placeholder 2"/>
+          <p:cNvSpPr>
+            <a:spLocks noGrp="1"/>
+          </p:cNvSpPr>
+          <p:nvPr>
+            <p:ph idx="1"/>
+          </p:nvPr>
+        </p:nvSpPr>
+        <p:spPr/>
+        <p:txBody>
+          <a:bodyPr/>
+          <a:lstStyle/>
+          <a:p>
+            <a:pPr>
+              <a:defRPr b="1" sz="2000"/>
+            </a:pPr>
+            <a:r>
+              <a:t>Three-Part Incentive Chain for Code Execution</a:t>
+            </a:r>
+          </a:p>
+          <a:p>
+            <a:pPr>
+              <a:defRPr b="1" sz="1600"/>
+            </a:pPr>
+            <a:r>
+              <a:t>1. Prompt (Instruction)</a:t>
+            </a:r>
+          </a:p>
+          <a:p>
+            <a:pPr lvl="1">
+              <a:defRPr sz="1300"/>
+            </a:pPr>
+            <a:r>
+              <a:t>Solver prompt explicitly states:</a:t>
+            </a:r>
+          </a:p>
+          <a:p>
+            <a:pPr lvl="1">
+              <a:defRPr sz="1300"/>
+            </a:pPr>
+            <a:r>
+              <a:t>"Write Python code wrapped in &lt;code&gt;...&lt;/code&gt;"</a:t>
+            </a:r>
+          </a:p>
+          <a:p>
+            <a:pPr lvl="1">
+              <a:defRPr sz="1300"/>
+            </a:pPr>
+            <a:r>
+              <a:t>Provides inductive bias toward tool use</a:t>
+            </a:r>
+          </a:p>
+          <a:p>
+            <a:pPr>
+              <a:defRPr b="1" sz="1600"/>
+            </a:pPr>
+            <a:r>
+              <a:t>2. Extraction (Architecture)</a:t>
+            </a:r>
+          </a:p>
+          <a:p>
+            <a:pPr lvl="1">
+              <a:defRPr sz="1300"/>
+            </a:pPr>
+            <a:r>
+              <a:t>Only code in &lt;code&gt;...&lt;/code&gt; blocks is extracted</a:t>
+            </a:r>
+          </a:p>
+          <a:p>
+            <a:pPr lvl="1">
+              <a:defRPr sz="1300"/>
+            </a:pPr>
+            <a:r>
+              <a:t>No code found → tool_result.is_error = True</a:t>
+            </a:r>
+          </a:p>
+          <a:p>
+            <a:pPr lvl="1">
+              <a:defRPr sz="1300"/>
+            </a:pPr>
+            <a:r>
+              <a:t>This architectural choice enforces code writing</a:t>
+            </a:r>
+          </a:p>
+          <a:p>
+            <a:pPr>
+              <a:defRPr b="1" sz="1600"/>
+            </a:pPr>
+            <a:r>
+              <a:t>3. Reward (Loss Signal)</a:t>
+            </a:r>
+          </a:p>
+          <a:p>
+            <a:pPr lvl="1">
+              <a:defRPr sz="1300"/>
+            </a:pPr>
+            <a:r>
+              <a:t>No code written → is_error=True → reward = 0.0</a:t>
+            </a:r>
+          </a:p>
+          <a:p>
+            <a:pPr lvl="1">
+              <a:defRPr sz="1300"/>
+            </a:pPr>
+            <a:r>
+              <a:t>Code executes cleanly → 0.3 + 0.2 + 0.5 = up to 1.0</a:t>
+            </a:r>
+          </a:p>
+          <a:p>
+            <a:pPr lvl="1">
+              <a:defRPr sz="1300"/>
+            </a:pPr>
+            <a:r>
+              <a:t>Stark difference forces strong learning signal</a:t>
+            </a:r>
+          </a:p>
+          <a:p>
+            <a:pPr/>
+          </a:p>
+          <a:p>
+            <a:pPr>
+              <a:defRPr b="1" sz="1600"/>
+            </a:pPr>
+            <a:r>
+              <a:t>Solver Step Reward Breakdown (0.0-1.0)</a:t>
+            </a:r>
+          </a:p>
+          <a:p>
+            <a:pPr lvl="1">
+              <a:defRPr sz="1300"/>
+            </a:pPr>
+            <a:r>
+              <a:t>0.3 — Tool executed without Python error</a:t>
+            </a:r>
+          </a:p>
+          <a:p>
+            <a:pPr lvl="1">
+              <a:defRPr sz="1300"/>
+            </a:pPr>
+            <a:r>
+              <a:t>0.2 — Output is sensible (non-empty, &lt; 256 chars)</a:t>
+            </a:r>
+          </a:p>
+          <a:p>
+            <a:pPr lvl="1">
+              <a:defRPr sz="1300"/>
+            </a:pPr>
+            <a:r>
+              <a:t>0.5 — Final answer is correct (outcome signal)</a:t>
+            </a:r>
+          </a:p>
+          <a:p>
+            <a:pPr/>
+          </a:p>
+          <a:p>
+            <a:pPr>
+              <a:defRPr b="1" sz="1600"/>
+            </a:pPr>
+            <a:r>
+              <a:t>Why This Design?</a:t>
+            </a:r>
+          </a:p>
+          <a:p>
+            <a:pPr lvl="1">
+              <a:defRPr sz="1300"/>
+            </a:pPr>
+            <a:r>
+              <a:t>Forces verifiable computation: code either runs or fails</a:t>
+            </a:r>
+          </a:p>
+          <a:p>
+            <a:pPr lvl="1">
+              <a:defRPr sz="1300"/>
+            </a:pPr>
+            <a:r>
+              <a:t>Avoids ambiguity: prose answers can be interpreted many ways</a:t>
+            </a:r>
+          </a:p>
+          <a:p>
+            <a:pPr lvl="1">
+              <a:defRPr sz="1300"/>
+            </a:pPr>
+            <a:r>
+              <a:t>Enables debugging: can inspect tool outputs and errors</a:t>
+            </a:r>
+          </a:p>
+          <a:p>
+            <a:pPr lvl="1">
+              <a:defRPr sz="1300"/>
+            </a:pPr>
+            <a:r>
+              <a:t>Prevents hallucination: LLM can't claim arbitrary answers</a:t>
             </a:r>
           </a:p>
         </p:txBody>

</xml_diff>